<commit_message>
fix bug and update webscraping logic
</commit_message>
<xml_diff>
--- a/backend/output/robottikoiravalvonta_vr_seurannalla/powerpoint/second_testing_template.pptx
+++ b/backend/output/robottikoiravalvonta_vr_seurannalla/powerpoint/second_testing_template.pptx
@@ -3186,7 +3186,7 @@
                   <a:cs typeface="Gilda Display"/>
                   <a:sym typeface="Gilda Display"/>
                 </a:rPr>
-                <a:t>Robottikoiravalvonta VR</a:t>
+                <a:t>Robottikoiravalvonta VR-seurannalla</a:t>
               </a:r>
             </a:p>
           </p:txBody>
@@ -3227,7 +3227,7 @@
                   <a:cs typeface="HK Grotesk Light"/>
                   <a:sym typeface="HK Grotesk Light"/>
                 </a:rPr>
-                <a:t>Langaton 360-kuvan siirto vaarallisilla alueilla</a:t>
+                <a:t>Langaton 360-kuvan siirto</a:t>
               </a:r>
             </a:p>
           </p:txBody>
@@ -3276,7 +3276,7 @@
       </p:grpSp>
       <p:pic>
         <p:nvPicPr>
-          <p:cNvPr id="9" name="Picture 8" descr="download_image0.png"/>
+          <p:cNvPr id="9" name="Picture 8" descr="download_image1.png"/>
           <p:cNvPicPr>
             <a:picLocks noChangeAspect="1"/>
           </p:cNvPicPr>

</xml_diff>